<commit_message>
Update README and finalize capstone project
</commit_message>
<xml_diff>
--- a/novaretail_quarterly_review.pptx
+++ b/novaretail_quarterly_review.pptx
@@ -4,9 +4,6 @@
   <p:sldMasterIdLst>
     <p:sldMasterId id="2147483648" r:id="rId1"/>
   </p:sldMasterIdLst>
-  <p:notesMasterIdLst>
-    <p:notesMasterId r:id="rId7"/>
-  </p:notesMasterIdLst>
   <p:sldIdLst>
     <p:sldId id="256" r:id="rId2"/>
     <p:sldId id="257" r:id="rId3"/>
@@ -14,6 +11,9 @@
     <p:sldId id="259" r:id="rId5"/>
     <p:sldId id="260" r:id="rId6"/>
   </p:sldIdLst>
+  <p:notesMasterIdLst>
+    <p:notesMasterId r:id="rId7"/>
+  </p:notesMasterIdLst>
   <p:sldSz cx="12192000" cy="6858000"/>
   <p:notesSz cx="6858000" cy="12192000"/>
   <p:defaultTextStyle>
@@ -108,20 +108,12 @@
       </a:defRPr>
     </a:lvl9pPr>
   </p:defaultTextStyle>
-  <p:extLst>
-    <p:ext uri="{EFAFB233-063F-42B5-8137-9DF3F51BA10A}">
-      <p15:sldGuideLst xmlns:p15="http://schemas.microsoft.com/office/powerpoint/2012/main"/>
-    </p:ext>
-  </p:extLst>
 </p:presentation>
 </file>
 
 <file path=ppt/charts/chart1.xml><?xml version="1.0" encoding="utf-8"?>
-<c:chartSpace xmlns:c="http://schemas.openxmlformats.org/drawingml/2006/chart" xmlns:a="http://schemas.openxmlformats.org/drawingml/2006/main" xmlns:r="http://schemas.openxmlformats.org/officeDocument/2006/relationships" xmlns:c16r2="http://schemas.microsoft.com/office/drawing/2015/06/chart">
+<c:chartSpace xmlns:c="http://schemas.openxmlformats.org/drawingml/2006/chart" xmlns:a="http://schemas.openxmlformats.org/drawingml/2006/main" xmlns:r="http://schemas.openxmlformats.org/officeDocument/2006/relationships">
   <c:date1904 val="0"/>
-  <c:lang val="en-US"/>
-  <c:roundedCorners val="1"/>
-  <c:style val="2"/>
   <c:chart>
     <c:title>
       <c:tx>
@@ -130,21 +122,19 @@
           <a:lstStyle/>
           <a:p>
             <a:r>
-              <a:rPr lang="en-US"/>
               <a:t>Revenue by Region Across Quarters</a:t>
             </a:r>
           </a:p>
         </c:rich>
       </c:tx>
+      <c:layout/>
       <c:overlay val="0"/>
     </c:title>
     <c:autoTitleDeleted val="0"/>
     <c:plotArea>
-      <c:layout/>
       <c:barChart>
         <c:barDir val="col"/>
         <c:grouping val="clustered"/>
-        <c:varyColors val="1"/>
         <c:ser>
           <c:idx val="0"/>
           <c:order val="0"/>
@@ -159,7 +149,6 @@
               </c:strCache>
             </c:strRef>
           </c:tx>
-          <c:invertIfNegative val="1"/>
           <c:cat>
             <c:strRef>
               <c:f>Sheet1!$A$2:$A$5</c:f>
@@ -187,25 +176,20 @@
                 <c:formatCode>General</c:formatCode>
                 <c:ptCount val="4"/>
                 <c:pt idx="0">
-                  <c:v>305</c:v>
+                  <c:v>305.0</c:v>
                 </c:pt>
                 <c:pt idx="1">
-                  <c:v>330</c:v>
+                  <c:v>330.0</c:v>
                 </c:pt>
                 <c:pt idx="2">
-                  <c:v>150</c:v>
+                  <c:v>150.0</c:v>
                 </c:pt>
                 <c:pt idx="3">
-                  <c:v>440</c:v>
+                  <c:v>440.0</c:v>
                 </c:pt>
               </c:numCache>
             </c:numRef>
           </c:val>
-          <c:extLst>
-            <c:ext xmlns:c16="http://schemas.microsoft.com/office/drawing/2014/chart" uri="{C3380CC4-5D6E-409C-BE32-E72D297353CC}">
-              <c16:uniqueId val="{00000000-4028-47FA-8BF7-AF5780F82A7D}"/>
-            </c:ext>
-          </c:extLst>
         </c:ser>
         <c:ser>
           <c:idx val="1"/>
@@ -221,7 +205,6 @@
               </c:strCache>
             </c:strRef>
           </c:tx>
-          <c:invertIfNegative val="1"/>
           <c:cat>
             <c:strRef>
               <c:f>Sheet1!$A$2:$A$5</c:f>
@@ -249,35 +232,21 @@
                 <c:formatCode>General</c:formatCode>
                 <c:ptCount val="4"/>
                 <c:pt idx="0">
-                  <c:v>330</c:v>
+                  <c:v>330.0</c:v>
                 </c:pt>
                 <c:pt idx="1">
-                  <c:v>345</c:v>
+                  <c:v>345.0</c:v>
                 </c:pt>
                 <c:pt idx="2">
-                  <c:v>140</c:v>
+                  <c:v>140.0</c:v>
                 </c:pt>
                 <c:pt idx="3">
-                  <c:v>465</c:v>
+                  <c:v>465.0</c:v>
                 </c:pt>
               </c:numCache>
             </c:numRef>
           </c:val>
-          <c:extLst>
-            <c:ext xmlns:c16="http://schemas.microsoft.com/office/drawing/2014/chart" uri="{C3380CC4-5D6E-409C-BE32-E72D297353CC}">
-              <c16:uniqueId val="{00000001-4028-47FA-8BF7-AF5780F82A7D}"/>
-            </c:ext>
-          </c:extLst>
         </c:ser>
-        <c:dLbls>
-          <c:showLegendKey val="0"/>
-          <c:showVal val="0"/>
-          <c:showCatName val="0"/>
-          <c:showSerName val="0"/>
-          <c:showPercent val="0"/>
-          <c:showBubbleSize val="0"/>
-        </c:dLbls>
-        <c:gapWidth val="150"/>
         <c:axId val="-2068027336"/>
         <c:axId val="-2113994440"/>
       </c:barChart>
@@ -288,7 +257,6 @@
         </c:scaling>
         <c:delete val="0"/>
         <c:axPos val="b"/>
-        <c:numFmt formatCode="General" sourceLinked="0"/>
         <c:majorTickMark val="out"/>
         <c:minorTickMark val="none"/>
         <c:tickLblPos val="nextTo"/>
@@ -301,28 +269,21 @@
       </c:catAx>
       <c:valAx>
         <c:axId val="-2113994440"/>
-        <c:scaling>
-          <c:orientation val="minMax"/>
-        </c:scaling>
+        <c:scaling/>
         <c:delete val="0"/>
         <c:axPos val="l"/>
         <c:majorGridlines/>
-        <c:numFmt formatCode="General" sourceLinked="1"/>
         <c:majorTickMark val="out"/>
         <c:minorTickMark val="none"/>
         <c:tickLblPos val="nextTo"/>
         <c:crossAx val="-2068027336"/>
         <c:crosses val="autoZero"/>
-        <c:crossBetween val="between"/>
       </c:valAx>
     </c:plotArea>
     <c:legend>
-      <c:legendPos val="r"/>
       <c:overlay val="0"/>
     </c:legend>
-    <c:plotVisOnly val="1"/>
     <c:dispBlanksAs val="gap"/>
-    <c:showDLblsOverMax val="1"/>
   </c:chart>
   <c:txPr>
     <a:bodyPr/>
@@ -341,11 +302,8 @@
 </file>
 
 <file path=ppt/charts/chart2.xml><?xml version="1.0" encoding="utf-8"?>
-<c:chartSpace xmlns:c="http://schemas.openxmlformats.org/drawingml/2006/chart" xmlns:a="http://schemas.openxmlformats.org/drawingml/2006/main" xmlns:r="http://schemas.openxmlformats.org/officeDocument/2006/relationships" xmlns:c16r2="http://schemas.microsoft.com/office/drawing/2015/06/chart">
+<c:chartSpace xmlns:c="http://schemas.openxmlformats.org/drawingml/2006/chart" xmlns:a="http://schemas.openxmlformats.org/drawingml/2006/main" xmlns:r="http://schemas.openxmlformats.org/officeDocument/2006/relationships">
   <c:date1904 val="0"/>
-  <c:lang val="en-US"/>
-  <c:roundedCorners val="1"/>
-  <c:style val="2"/>
   <c:chart>
     <c:title>
       <c:tx>
@@ -354,21 +312,19 @@
           <a:lstStyle/>
           <a:p>
             <a:r>
-              <a:rPr lang="en-US"/>
-              <a:t>Average NPS by Region</a:t>
+              <a:t>NPS by Region | 2026-Q2</a:t>
             </a:r>
           </a:p>
         </c:rich>
       </c:tx>
+      <c:layout/>
       <c:overlay val="0"/>
     </c:title>
     <c:autoTitleDeleted val="0"/>
     <c:plotArea>
-      <c:layout/>
       <c:barChart>
         <c:barDir val="col"/>
         <c:grouping val="clustered"/>
-        <c:varyColors val="1"/>
         <c:ser>
           <c:idx val="0"/>
           <c:order val="0"/>
@@ -383,7 +339,6 @@
               </c:strCache>
             </c:strRef>
           </c:tx>
-          <c:invertIfNegative val="1"/>
           <c:cat>
             <c:strRef>
               <c:f>Sheet1!$A$2:$A$5</c:f>
@@ -411,35 +366,21 @@
                 <c:formatCode>General</c:formatCode>
                 <c:ptCount val="4"/>
                 <c:pt idx="0">
-                  <c:v>62</c:v>
+                  <c:v>62.0</c:v>
                 </c:pt>
                 <c:pt idx="1">
-                  <c:v>53</c:v>
+                  <c:v>53.0</c:v>
                 </c:pt>
                 <c:pt idx="2">
-                  <c:v>29</c:v>
+                  <c:v>29.0</c:v>
                 </c:pt>
                 <c:pt idx="3">
-                  <c:v>55</c:v>
+                  <c:v>55.0</c:v>
                 </c:pt>
               </c:numCache>
             </c:numRef>
           </c:val>
-          <c:extLst>
-            <c:ext xmlns:c16="http://schemas.microsoft.com/office/drawing/2014/chart" uri="{C3380CC4-5D6E-409C-BE32-E72D297353CC}">
-              <c16:uniqueId val="{00000000-2B34-44CE-AE26-8B751509EC36}"/>
-            </c:ext>
-          </c:extLst>
         </c:ser>
-        <c:dLbls>
-          <c:showLegendKey val="0"/>
-          <c:showVal val="0"/>
-          <c:showCatName val="0"/>
-          <c:showSerName val="0"/>
-          <c:showPercent val="0"/>
-          <c:showBubbleSize val="0"/>
-        </c:dLbls>
-        <c:gapWidth val="150"/>
         <c:axId val="-2068027336"/>
         <c:axId val="-2113994440"/>
       </c:barChart>
@@ -450,7 +391,6 @@
         </c:scaling>
         <c:delete val="0"/>
         <c:axPos val="b"/>
-        <c:numFmt formatCode="General" sourceLinked="0"/>
         <c:majorTickMark val="out"/>
         <c:minorTickMark val="none"/>
         <c:tickLblPos val="nextTo"/>
@@ -463,24 +403,18 @@
       </c:catAx>
       <c:valAx>
         <c:axId val="-2113994440"/>
-        <c:scaling>
-          <c:orientation val="minMax"/>
-        </c:scaling>
+        <c:scaling/>
         <c:delete val="0"/>
         <c:axPos val="l"/>
         <c:majorGridlines/>
-        <c:numFmt formatCode="General" sourceLinked="1"/>
         <c:majorTickMark val="out"/>
         <c:minorTickMark val="none"/>
         <c:tickLblPos val="nextTo"/>
         <c:crossAx val="-2068027336"/>
         <c:crosses val="autoZero"/>
-        <c:crossBetween val="between"/>
       </c:valAx>
     </c:plotArea>
-    <c:plotVisOnly val="1"/>
     <c:dispBlanksAs val="gap"/>
-    <c:showDLblsOverMax val="1"/>
   </c:chart>
   <c:txPr>
     <a:bodyPr/>
@@ -499,11 +433,8 @@
 </file>
 
 <file path=ppt/charts/chart3.xml><?xml version="1.0" encoding="utf-8"?>
-<c:chartSpace xmlns:c="http://schemas.openxmlformats.org/drawingml/2006/chart" xmlns:a="http://schemas.openxmlformats.org/drawingml/2006/main" xmlns:r="http://schemas.openxmlformats.org/officeDocument/2006/relationships" xmlns:c16r2="http://schemas.microsoft.com/office/drawing/2015/06/chart">
+<c:chartSpace xmlns:c="http://schemas.openxmlformats.org/drawingml/2006/chart" xmlns:a="http://schemas.openxmlformats.org/drawingml/2006/main" xmlns:r="http://schemas.openxmlformats.org/officeDocument/2006/relationships">
   <c:date1904 val="0"/>
-  <c:lang val="en-US"/>
-  <c:roundedCorners val="1"/>
-  <c:style val="2"/>
   <c:chart>
     <c:title>
       <c:tx>
@@ -512,21 +443,19 @@
           <a:lstStyle/>
           <a:p>
             <a:r>
-              <a:rPr lang="en-US"/>
               <a:t>Stockout Rate by Region</a:t>
             </a:r>
           </a:p>
         </c:rich>
       </c:tx>
+      <c:layout/>
       <c:overlay val="0"/>
     </c:title>
     <c:autoTitleDeleted val="0"/>
     <c:plotArea>
-      <c:layout/>
       <c:barChart>
         <c:barDir val="col"/>
         <c:grouping val="clustered"/>
-        <c:varyColors val="1"/>
         <c:ser>
           <c:idx val="0"/>
           <c:order val="0"/>
@@ -541,7 +470,6 @@
               </c:strCache>
             </c:strRef>
           </c:tx>
-          <c:invertIfNegative val="1"/>
           <c:cat>
             <c:strRef>
               <c:f>Sheet1!$A$2:$A$5</c:f>
@@ -572,7 +500,7 @@
                   <c:v>8.5</c:v>
                 </c:pt>
                 <c:pt idx="1">
-                  <c:v>4</c:v>
+                  <c:v>4.0</c:v>
                 </c:pt>
                 <c:pt idx="2">
                   <c:v>12.5</c:v>
@@ -583,21 +511,7 @@
               </c:numCache>
             </c:numRef>
           </c:val>
-          <c:extLst>
-            <c:ext xmlns:c16="http://schemas.microsoft.com/office/drawing/2014/chart" uri="{C3380CC4-5D6E-409C-BE32-E72D297353CC}">
-              <c16:uniqueId val="{00000000-AE75-45D1-B8FF-9067A6D1C3FB}"/>
-            </c:ext>
-          </c:extLst>
         </c:ser>
-        <c:dLbls>
-          <c:showLegendKey val="0"/>
-          <c:showVal val="0"/>
-          <c:showCatName val="0"/>
-          <c:showSerName val="0"/>
-          <c:showPercent val="0"/>
-          <c:showBubbleSize val="0"/>
-        </c:dLbls>
-        <c:gapWidth val="150"/>
         <c:axId val="-2068027336"/>
         <c:axId val="-2113994440"/>
       </c:barChart>
@@ -608,7 +522,6 @@
         </c:scaling>
         <c:delete val="0"/>
         <c:axPos val="b"/>
-        <c:numFmt formatCode="General" sourceLinked="0"/>
         <c:majorTickMark val="out"/>
         <c:minorTickMark val="none"/>
         <c:tickLblPos val="nextTo"/>
@@ -621,24 +534,18 @@
       </c:catAx>
       <c:valAx>
         <c:axId val="-2113994440"/>
-        <c:scaling>
-          <c:orientation val="minMax"/>
-        </c:scaling>
+        <c:scaling/>
         <c:delete val="0"/>
         <c:axPos val="l"/>
         <c:majorGridlines/>
-        <c:numFmt formatCode="General" sourceLinked="1"/>
         <c:majorTickMark val="out"/>
         <c:minorTickMark val="none"/>
         <c:tickLblPos val="nextTo"/>
         <c:crossAx val="-2068027336"/>
         <c:crosses val="autoZero"/>
-        <c:crossBetween val="between"/>
       </c:valAx>
     </c:plotArea>
-    <c:plotVisOnly val="1"/>
     <c:dispBlanksAs val="gap"/>
-    <c:showDLblsOverMax val="1"/>
   </c:chart>
   <c:txPr>
     <a:bodyPr/>
@@ -678,10 +585,234 @@
           <a:chExt cx="0" cy="0"/>
         </a:xfrm>
       </p:grpSpPr>
+      <p:sp>
+        <p:nvSpPr>
+          <p:cNvPr id="2" name="Header Placeholder 1"/>
+          <p:cNvSpPr>
+            <a:spLocks noGrp="1"/>
+          </p:cNvSpPr>
+          <p:nvPr>
+            <p:ph type="hdr" sz="quarter"/>
+          </p:nvPr>
+        </p:nvSpPr>
+        <p:spPr>
+          <a:xfrm>
+            <a:off x="0" y="0"/>
+            <a:ext cx="2971800" cy="458788"/>
+          </a:xfrm>
+          <a:prstGeom prst="rect">
+            <a:avLst/>
+          </a:prstGeom>
+        </p:spPr>
+        <p:txBody>
+          <a:bodyPr vert="horz" lIns="91440" tIns="45720" rIns="91440" bIns="45720" rtlCol="0"/>
+          <a:lstStyle>
+            <a:lvl1pPr algn="l">
+              <a:defRPr sz="1200"/>
+            </a:lvl1pPr>
+          </a:lstStyle>
+          <a:p>
+            <a:endParaRPr lang="en-US"/>
+          </a:p>
+        </p:txBody>
+      </p:sp>
+      <p:sp>
+        <p:nvSpPr>
+          <p:cNvPr id="3" name="Date Placeholder 2"/>
+          <p:cNvSpPr>
+            <a:spLocks noGrp="1"/>
+          </p:cNvSpPr>
+          <p:nvPr>
+            <p:ph type="dt" idx="1"/>
+          </p:nvPr>
+        </p:nvSpPr>
+        <p:spPr>
+          <a:xfrm>
+            <a:off x="3884613" y="0"/>
+            <a:ext cx="2971800" cy="458788"/>
+          </a:xfrm>
+          <a:prstGeom prst="rect">
+            <a:avLst/>
+          </a:prstGeom>
+        </p:spPr>
+        <p:txBody>
+          <a:bodyPr vert="horz" lIns="91440" tIns="45720" rIns="91440" bIns="45720" rtlCol="0"/>
+          <a:lstStyle>
+            <a:lvl1pPr algn="r">
+              <a:defRPr sz="1200"/>
+            </a:lvl1pPr>
+          </a:lstStyle>
+          <a:p>
+            <a:fld id="{5282F153-3F37-0F45-9E97-73ACFA13230C}" type="datetimeFigureOut">
+              <a:rPr lang="en-US"/>
+              <a:t>7/23/19</a:t>
+            </a:fld>
+            <a:endParaRPr lang="en-US"/>
+          </a:p>
+        </p:txBody>
+      </p:sp>
+      <p:sp>
+        <p:nvSpPr>
+          <p:cNvPr id="4" name="Slide Image Placeholder 3"/>
+          <p:cNvSpPr>
+            <a:spLocks noGrp="1" noRot="1" noChangeAspect="1"/>
+          </p:cNvSpPr>
+          <p:nvPr>
+            <p:ph type="sldImg" idx="2"/>
+          </p:nvPr>
+        </p:nvSpPr>
+        <p:spPr>
+          <a:xfrm>
+            <a:off x="685800" y="1143000"/>
+            <a:ext cx="5486400" cy="3086100"/>
+          </a:xfrm>
+          <a:prstGeom prst="rect">
+            <a:avLst/>
+          </a:prstGeom>
+          <a:noFill/>
+          <a:ln w="12700">
+            <a:solidFill>
+              <a:prstClr val="black"/>
+            </a:solidFill>
+          </a:ln>
+        </p:spPr>
+        <p:txBody>
+          <a:bodyPr vert="horz" lIns="91440" tIns="45720" rIns="91440" bIns="45720" rtlCol="0" anchor="ctr"/>
+          <a:lstStyle/>
+          <a:p>
+            <a:endParaRPr lang="en-US"/>
+          </a:p>
+        </p:txBody>
+      </p:sp>
+      <p:sp>
+        <p:nvSpPr>
+          <p:cNvPr id="5" name="Notes Placeholder 4"/>
+          <p:cNvSpPr>
+            <a:spLocks noGrp="1"/>
+          </p:cNvSpPr>
+          <p:nvPr>
+            <p:ph type="body" sz="quarter" idx="3"/>
+          </p:nvPr>
+        </p:nvSpPr>
+        <p:spPr>
+          <a:xfrm>
+            <a:off x="685800" y="4400550"/>
+            <a:ext cx="5486400" cy="3600450"/>
+          </a:xfrm>
+          <a:prstGeom prst="rect">
+            <a:avLst/>
+          </a:prstGeom>
+        </p:spPr>
+        <p:txBody>
+          <a:bodyPr vert="horz" lIns="91440" tIns="45720" rIns="91440" bIns="45720" rtlCol="0"/>
+          <a:lstStyle/>
+          <a:p>
+            <a:pPr lvl="0"/>
+            <a:r>
+              <a:rPr lang="en-US"/>
+              <a:t>Click to edit Master text styles</a:t>
+            </a:r>
+          </a:p>
+          <a:p>
+            <a:pPr lvl="1"/>
+            <a:r>
+              <a:rPr lang="en-US"/>
+              <a:t>Second level</a:t>
+            </a:r>
+          </a:p>
+          <a:p>
+            <a:pPr lvl="2"/>
+            <a:r>
+              <a:rPr lang="en-US"/>
+              <a:t>Third level</a:t>
+            </a:r>
+          </a:p>
+          <a:p>
+            <a:pPr lvl="3"/>
+            <a:r>
+              <a:rPr lang="en-US"/>
+              <a:t>Fourth level</a:t>
+            </a:r>
+          </a:p>
+          <a:p>
+            <a:pPr lvl="4"/>
+            <a:r>
+              <a:rPr lang="en-US"/>
+              <a:t>Fifth level</a:t>
+            </a:r>
+          </a:p>
+        </p:txBody>
+      </p:sp>
+      <p:sp>
+        <p:nvSpPr>
+          <p:cNvPr id="6" name="Footer Placeholder 5"/>
+          <p:cNvSpPr>
+            <a:spLocks noGrp="1"/>
+          </p:cNvSpPr>
+          <p:nvPr>
+            <p:ph type="ftr" sz="quarter" idx="4"/>
+          </p:nvPr>
+        </p:nvSpPr>
+        <p:spPr>
+          <a:xfrm>
+            <a:off x="0" y="8685213"/>
+            <a:ext cx="2971800" cy="458787"/>
+          </a:xfrm>
+          <a:prstGeom prst="rect">
+            <a:avLst/>
+          </a:prstGeom>
+        </p:spPr>
+        <p:txBody>
+          <a:bodyPr vert="horz" lIns="91440" tIns="45720" rIns="91440" bIns="45720" rtlCol="0" anchor="b"/>
+          <a:lstStyle>
+            <a:lvl1pPr algn="l">
+              <a:defRPr sz="1200"/>
+            </a:lvl1pPr>
+          </a:lstStyle>
+          <a:p>
+            <a:endParaRPr lang="en-US"/>
+          </a:p>
+        </p:txBody>
+      </p:sp>
+      <p:sp>
+        <p:nvSpPr>
+          <p:cNvPr id="7" name="Slide Number Placeholder 6"/>
+          <p:cNvSpPr>
+            <a:spLocks noGrp="1"/>
+          </p:cNvSpPr>
+          <p:nvPr>
+            <p:ph type="sldNum" sz="quarter" idx="5"/>
+          </p:nvPr>
+        </p:nvSpPr>
+        <p:spPr>
+          <a:xfrm>
+            <a:off x="3884613" y="8685213"/>
+            <a:ext cx="2971800" cy="458787"/>
+          </a:xfrm>
+          <a:prstGeom prst="rect">
+            <a:avLst/>
+          </a:prstGeom>
+        </p:spPr>
+        <p:txBody>
+          <a:bodyPr vert="horz" lIns="91440" tIns="45720" rIns="91440" bIns="45720" rtlCol="0" anchor="b"/>
+          <a:lstStyle>
+            <a:lvl1pPr algn="r">
+              <a:defRPr sz="1200"/>
+            </a:lvl1pPr>
+          </a:lstStyle>
+          <a:p>
+            <a:fld id="{CE5E9CC1-C706-0F49-92D6-E571CC5EEA8F}" type="slidenum">
+              <a:rPr lang="en-US"/>
+              <a:t>‹#›</a:t>
+            </a:fld>
+            <a:endParaRPr lang="en-US"/>
+          </a:p>
+        </p:txBody>
+      </p:sp>
     </p:spTree>
     <p:extLst>
       <p:ext uri="{BB962C8B-B14F-4D97-AF65-F5344CB8AC3E}">
-        <p14:creationId xmlns:p14="http://schemas.microsoft.com/office/powerpoint/2010/main" val="2304732892"/>
+        <p14:creationId xmlns:p14="http://schemas.microsoft.com/office/powerpoint/2010/main" val="1024086991"/>
       </p:ext>
     </p:extLst>
   </p:cSld>
@@ -825,6 +956,10 @@
           <a:bodyPr/>
           <a:lstStyle/>
           <a:p>
+            <a:r>
+              <a:rPr lang="en-US" dirty="0"/>
+              <a:t/>
+            </a:r>
             <a:endParaRPr lang="en-US" dirty="0"/>
           </a:p>
         </p:txBody>
@@ -909,6 +1044,10 @@
           <a:bodyPr/>
           <a:lstStyle/>
           <a:p>
+            <a:r>
+              <a:rPr lang="en-US" dirty="0"/>
+              <a:t/>
+            </a:r>
             <a:endParaRPr lang="en-US" dirty="0"/>
           </a:p>
         </p:txBody>
@@ -993,6 +1132,10 @@
           <a:bodyPr/>
           <a:lstStyle/>
           <a:p>
+            <a:r>
+              <a:rPr lang="en-US" dirty="0"/>
+              <a:t/>
+            </a:r>
             <a:endParaRPr lang="en-US" dirty="0"/>
           </a:p>
         </p:txBody>
@@ -1077,6 +1220,10 @@
           <a:bodyPr/>
           <a:lstStyle/>
           <a:p>
+            <a:r>
+              <a:rPr lang="en-US" dirty="0"/>
+              <a:t/>
+            </a:r>
             <a:endParaRPr lang="en-US" dirty="0"/>
           </a:p>
         </p:txBody>
@@ -1161,6 +1308,10 @@
           <a:bodyPr/>
           <a:lstStyle/>
           <a:p>
+            <a:r>
+              <a:rPr lang="en-US" dirty="0"/>
+              <a:t/>
+            </a:r>
             <a:endParaRPr lang="en-US" dirty="0"/>
           </a:p>
         </p:txBody>
@@ -1234,11 +1385,6 @@
 <file path=ppt/slideMasters/slideMaster1.xml><?xml version="1.0" encoding="utf-8"?>
 <p:sldMaster xmlns:a="http://schemas.openxmlformats.org/drawingml/2006/main" xmlns:r="http://schemas.openxmlformats.org/officeDocument/2006/relationships" xmlns:p="http://schemas.openxmlformats.org/presentationml/2006/main">
   <p:cSld>
-    <p:bg>
-      <p:bgRef idx="1001">
-        <a:schemeClr val="bg1"/>
-      </p:bgRef>
-    </p:bg>
     <p:spTree>
       <p:nvGrpSpPr>
         <p:cNvPr id="1" name=""/>
@@ -1253,54 +1399,6 @@
           <a:chExt cx="0" cy="0"/>
         </a:xfrm>
       </p:grpSpPr>
-      <p:sp>
-        <p:nvSpPr>
-          <p:cNvPr id="3" name="TextBox 2">
-            <a:extLst>
-              <a:ext uri="{FF2B5EF4-FFF2-40B4-BE49-F238E27FC236}">
-                <a16:creationId xmlns:a16="http://schemas.microsoft.com/office/drawing/2014/main" id="{47BC4C19-D015-5A8A-7D8C-263AD3DC9463}"/>
-              </a:ext>
-            </a:extLst>
-          </p:cNvPr>
-          <p:cNvSpPr txBox="1"/>
-          <p:nvPr userDrawn="1">
-            <p:extLst>
-              <p:ext uri="{1162E1C5-73C7-4A58-AE30-91384D911F3F}">
-                <p184:classification xmlns:p184="http://schemas.microsoft.com/office/powerpoint/2018/4/main" val="ftr"/>
-              </p:ext>
-            </p:extLst>
-          </p:nvPr>
-        </p:nvSpPr>
-        <p:spPr>
-          <a:xfrm>
-            <a:off x="63500" y="6672580"/>
-            <a:ext cx="855663" cy="121920"/>
-          </a:xfrm>
-          <a:prstGeom prst="rect">
-            <a:avLst/>
-          </a:prstGeom>
-        </p:spPr>
-        <p:txBody>
-          <a:bodyPr horzOverflow="overflow" lIns="0" tIns="0" rIns="0" bIns="0">
-            <a:spAutoFit/>
-          </a:bodyPr>
-          <a:lstStyle/>
-          <a:p>
-            <a:pPr algn="l"/>
-            <a:r>
-              <a:rPr lang="en-US" sz="800">
-                <a:solidFill>
-                  <a:srgbClr val="317100">
-                    <a:alpha val="50000"/>
-                  </a:srgbClr>
-                </a:solidFill>
-                <a:latin typeface="Aptos" panose="020B0004020202020204" pitchFamily="34" charset="0"/>
-              </a:rPr>
-              <a:t>Sensitivity: Internal</a:t>
-            </a:r>
-          </a:p>
-        </p:txBody>
-      </p:sp>
     </p:spTree>
   </p:cSld>
   <p:clrMap bg1="lt1" tx1="dk1" bg2="lt2" tx2="dk2" accent1="accent1" accent2="accent2" accent3="accent3" accent4="accent4" accent5="accent5" accent6="accent6" hlink="hlink" folHlink="folHlink"/>
@@ -1569,7 +1667,6 @@
         <a:solidFill>
           <a:srgbClr val="1E2761"/>
         </a:solidFill>
-        <a:effectLst/>
       </p:bgPr>
     </p:bg>
     <p:spTree>
@@ -1607,7 +1704,7 @@
           <a:bodyPr wrap="square" lIns="0" tIns="0" rIns="0" bIns="0" rtlCol="0" anchor="ctr"/>
           <a:lstStyle/>
           <a:p>
-            <a:pPr marL="0" indent="0" algn="l">
+            <a:pPr algn="l" indent="0" marL="0">
               <a:buNone/>
             </a:pPr>
             <a:r>
@@ -1646,7 +1743,7 @@
           <a:bodyPr wrap="square" lIns="0" tIns="0" rIns="0" bIns="0" rtlCol="0" anchor="ctr"/>
           <a:lstStyle/>
           <a:p>
-            <a:pPr marL="0" indent="0" algn="l">
+            <a:pPr algn="l" indent="0" marL="0">
               <a:buNone/>
               <a:defRPr sz="1200"/>
             </a:pPr>
@@ -1683,13 +1780,6 @@
           </a:solidFill>
           <a:ln/>
         </p:spPr>
-        <p:txBody>
-          <a:bodyPr/>
-          <a:lstStyle/>
-          <a:p>
-            <a:endParaRPr lang="en-US"/>
-          </a:p>
-        </p:txBody>
       </p:sp>
       <p:sp>
         <p:nvSpPr>
@@ -1712,7 +1802,7 @@
           <a:bodyPr wrap="square" lIns="0" tIns="0" rIns="0" bIns="0" rtlCol="0" anchor="ctr"/>
           <a:lstStyle/>
           <a:p>
-            <a:pPr marL="0" indent="0" algn="ctr">
+            <a:pPr algn="ctr" indent="0" marL="0">
               <a:buNone/>
               <a:defRPr sz="1200"/>
             </a:pPr>
@@ -1749,7 +1839,7 @@
           <a:bodyPr wrap="square" lIns="0" tIns="0" rIns="0" bIns="0" rtlCol="0" anchor="ctr"/>
           <a:lstStyle/>
           <a:p>
-            <a:pPr marL="0" indent="0" algn="ctr">
+            <a:pPr algn="ctr" indent="0" marL="0">
               <a:buNone/>
               <a:defRPr sz="1200"/>
             </a:pPr>
@@ -1786,13 +1876,6 @@
           </a:solidFill>
           <a:ln/>
         </p:spPr>
-        <p:txBody>
-          <a:bodyPr/>
-          <a:lstStyle/>
-          <a:p>
-            <a:endParaRPr lang="en-US"/>
-          </a:p>
-        </p:txBody>
       </p:sp>
       <p:sp>
         <p:nvSpPr>
@@ -1815,7 +1898,7 @@
           <a:bodyPr wrap="square" lIns="0" tIns="0" rIns="0" bIns="0" rtlCol="0" anchor="ctr"/>
           <a:lstStyle/>
           <a:p>
-            <a:pPr marL="0" indent="0" algn="ctr">
+            <a:pPr algn="ctr" indent="0" marL="0">
               <a:buNone/>
               <a:defRPr sz="1200"/>
             </a:pPr>
@@ -1852,7 +1935,7 @@
           <a:bodyPr wrap="square" lIns="0" tIns="0" rIns="0" bIns="0" rtlCol="0" anchor="ctr"/>
           <a:lstStyle/>
           <a:p>
-            <a:pPr marL="0" indent="0" algn="ctr">
+            <a:pPr algn="ctr" indent="0" marL="0">
               <a:buNone/>
               <a:defRPr sz="1200"/>
             </a:pPr>
@@ -1889,13 +1972,6 @@
           </a:solidFill>
           <a:ln/>
         </p:spPr>
-        <p:txBody>
-          <a:bodyPr/>
-          <a:lstStyle/>
-          <a:p>
-            <a:endParaRPr lang="en-US"/>
-          </a:p>
-        </p:txBody>
       </p:sp>
       <p:sp>
         <p:nvSpPr>
@@ -1918,7 +1994,7 @@
           <a:bodyPr wrap="square" lIns="0" tIns="0" rIns="0" bIns="0" rtlCol="0" anchor="ctr"/>
           <a:lstStyle/>
           <a:p>
-            <a:pPr marL="0" indent="0" algn="ctr">
+            <a:pPr algn="ctr" indent="0" marL="0">
               <a:buNone/>
               <a:defRPr sz="1200"/>
             </a:pPr>
@@ -1955,7 +2031,7 @@
           <a:bodyPr wrap="square" lIns="0" tIns="0" rIns="0" bIns="0" rtlCol="0" anchor="ctr"/>
           <a:lstStyle/>
           <a:p>
-            <a:pPr marL="0" indent="0" algn="ctr">
+            <a:pPr algn="ctr" indent="0" marL="0">
               <a:buNone/>
               <a:defRPr sz="1200"/>
             </a:pPr>
@@ -1992,11 +2068,11 @@
           <a:bodyPr wrap="square" lIns="0" tIns="0" rIns="0" bIns="0" rtlCol="0" anchor="ctr"/>
           <a:lstStyle/>
           <a:p>
-            <a:pPr marL="0" indent="0" algn="l">
+            <a:pPr algn="l" indent="0" marL="0">
               <a:buNone/>
             </a:pPr>
             <a:r>
-              <a:rPr lang="en-US" sz="1300" b="1" kern="0" spc="200" dirty="0">
+              <a:rPr lang="en-US" sz="1300" b="1" spc="200" kern="0" dirty="0">
                 <a:solidFill>
                   <a:srgbClr val="CADCFC"/>
                 </a:solidFill>
@@ -2031,7 +2107,7 @@
           <a:bodyPr wrap="square" lIns="0" tIns="0" rIns="0" bIns="0" rtlCol="0" anchor="t"/>
           <a:lstStyle/>
           <a:p>
-            <a:pPr marL="0" indent="0" algn="l">
+            <a:pPr algn="l" indent="0" marL="0">
               <a:buNone/>
               <a:defRPr sz="1200"/>
             </a:pPr>
@@ -2068,7 +2144,7 @@
           <a:bodyPr wrap="square" lIns="0" tIns="0" rIns="0" bIns="0" rtlCol="0" anchor="ctr"/>
           <a:lstStyle/>
           <a:p>
-            <a:pPr marL="0" indent="0" algn="l">
+            <a:pPr algn="l" indent="0" marL="0">
               <a:buNone/>
             </a:pPr>
             <a:r>
@@ -2107,7 +2183,7 @@
           <a:bodyPr wrap="square" lIns="0" tIns="0" rIns="0" bIns="0" rtlCol="0" anchor="ctr"/>
           <a:lstStyle/>
           <a:p>
-            <a:pPr marL="0" indent="0" algn="r">
+            <a:pPr algn="r" indent="0" marL="0">
               <a:buNone/>
             </a:pPr>
             <a:r>
@@ -2165,7 +2241,6 @@
         <a:solidFill>
           <a:srgbClr val="FFFFFF"/>
         </a:solidFill>
-        <a:effectLst/>
       </p:bgPr>
     </p:bg>
     <p:spTree>
@@ -2203,7 +2278,7 @@
           <a:bodyPr wrap="square" lIns="0" tIns="0" rIns="0" bIns="0" rtlCol="0" anchor="t"/>
           <a:lstStyle/>
           <a:p>
-            <a:pPr marL="0" indent="0" algn="l">
+            <a:pPr algn="l" indent="0" marL="0">
               <a:buNone/>
               <a:defRPr sz="1200"/>
             </a:pPr>
@@ -2240,7 +2315,7 @@
           <a:bodyPr wrap="square" lIns="0" tIns="0" rIns="0" bIns="0" rtlCol="0" anchor="t"/>
           <a:lstStyle/>
           <a:p>
-            <a:pPr marL="0" indent="0" algn="l">
+            <a:pPr algn="l" indent="0" marL="0">
               <a:buNone/>
               <a:defRPr sz="1200"/>
             </a:pPr>
@@ -2304,7 +2379,7 @@
           <a:bodyPr wrap="square" lIns="0" tIns="0" rIns="0" bIns="0" rtlCol="0" anchor="ctr"/>
           <a:lstStyle/>
           <a:p>
-            <a:pPr marL="0" indent="0" algn="l">
+            <a:pPr algn="l" indent="0" marL="0">
               <a:buNone/>
             </a:pPr>
             <a:r>
@@ -2343,7 +2418,7 @@
           <a:bodyPr wrap="square" lIns="0" tIns="0" rIns="0" bIns="0" rtlCol="0" anchor="ctr"/>
           <a:lstStyle/>
           <a:p>
-            <a:pPr marL="0" indent="0" algn="r">
+            <a:pPr algn="r" indent="0" marL="0">
               <a:buNone/>
             </a:pPr>
             <a:r>
@@ -2375,7 +2450,7 @@
         </p:xfrm>
         <a:graphic>
           <a:graphicData uri="http://schemas.openxmlformats.org/drawingml/2006/chart">
-            <c:chart xmlns:c="http://schemas.openxmlformats.org/drawingml/2006/chart" xmlns:r="http://schemas.openxmlformats.org/officeDocument/2006/relationships" r:id="rId3"/>
+            <c:chart xmlns:c="http://schemas.openxmlformats.org/drawingml/2006/chart" r:id="rId3"/>
           </a:graphicData>
         </a:graphic>
       </p:graphicFrame>
@@ -2419,7 +2494,6 @@
         <a:solidFill>
           <a:srgbClr val="FFFFFF"/>
         </a:solidFill>
-        <a:effectLst/>
       </p:bgPr>
     </p:bg>
     <p:spTree>
@@ -2457,19 +2531,139 @@
           <a:bodyPr wrap="square" lIns="0" tIns="0" rIns="0" bIns="0" rtlCol="0" anchor="t"/>
           <a:lstStyle/>
           <a:p>
-            <a:pPr marL="0" indent="0" algn="l">
+            <a:pPr algn="l" indent="0" marL="0">
               <a:buNone/>
               <a:defRPr sz="1200"/>
             </a:pPr>
             <a:r>
-              <a:rPr sz="2400" b="1">
-                <a:solidFill>
-                  <a:srgbClr val="1F2D5B"/>
-                </a:solidFill>
-              </a:rPr>
-              <a:t>Customer Advocacy Improves by 0.5 NPS Points</a:t>
+              <a:t>Customer Advocacy Diverges Sharply, with Latin America Trailing Other Regions</a:t>
             </a:r>
             <a:endParaRPr lang="en-US" sz="2400" dirty="0"/>
+          </a:p>
+        </p:txBody>
+      </p:sp>
+      <p:sp>
+        <p:nvSpPr>
+          <p:cNvPr id="4" name="chart_customer_label"/>
+          <p:cNvSpPr txBox="1"/>
+          <p:nvPr/>
+        </p:nvSpPr>
+        <p:spPr>
+          <a:xfrm>
+            <a:off x="685800" y="1581912"/>
+            <a:ext cx="6400800" cy="4471416"/>
+          </a:xfrm>
+          <a:prstGeom prst="rect">
+            <a:avLst/>
+          </a:prstGeom>
+          <a:noFill/>
+          <a:ln/>
+        </p:spPr>
+        <p:txBody>
+          <a:bodyPr wrap="square" lIns="0" tIns="0" rIns="0" bIns="0" rtlCol="0" anchor="t"/>
+          <a:lstStyle/>
+          <a:p>
+            <a:pPr algn="ctr" indent="0" marL="0">
+              <a:buNone/>
+            </a:pPr>
+            <a:r>
+              <a:rPr lang="en-US" sz="1300" b="1" dirty="0">
+                <a:solidFill>
+                  <a:srgbClr val="1E2761"/>
+                </a:solidFill>
+                <a:latin typeface="Calibri" pitchFamily="34" charset="0"/>
+                <a:ea typeface="Calibri" pitchFamily="34" charset="-122"/>
+                <a:cs typeface="Calibri" pitchFamily="34" charset="-120"/>
+              </a:rPr>
+              <a:t>CHART
+</a:t>
+            </a:r>
+            <a:endParaRPr lang="en-US" sz="1300" dirty="0"/>
+          </a:p>
+          <a:p>
+            <a:pPr algn="ctr" indent="0" marL="0">
+              <a:buNone/>
+            </a:pPr>
+            <a:r>
+              <a:rPr lang="en-US" sz="1050" i="1" dirty="0">
+                <a:solidFill>
+                  <a:srgbClr val="1E2761"/>
+                </a:solidFill>
+                <a:latin typeface="Calibri" pitchFamily="34" charset="0"/>
+                <a:ea typeface="Calibri" pitchFamily="34" charset="-122"/>
+                <a:cs typeface="Calibri" pitchFamily="34" charset="-120"/>
+              </a:rPr>
+              <a:t>Insert your chart here.</a:t>
+            </a:r>
+            <a:endParaRPr lang="en-US" sz="1300" dirty="0"/>
+          </a:p>
+          <a:p>
+            <a:pPr algn="ctr" indent="0" marL="0">
+              <a:buNone/>
+            </a:pPr>
+            <a:r>
+              <a:rPr lang="en-US" sz="1050" i="1" dirty="0">
+                <a:solidFill>
+                  <a:srgbClr val="1E2761"/>
+                </a:solidFill>
+                <a:latin typeface="Calibri" pitchFamily="34" charset="0"/>
+                <a:ea typeface="Calibri" pitchFamily="34" charset="-122"/>
+                <a:cs typeface="Calibri" pitchFamily="34" charset="-120"/>
+              </a:rPr>
+              <a:t>Suggested: line chart of</a:t>
+            </a:r>
+            <a:endParaRPr lang="en-US" sz="1300" dirty="0"/>
+          </a:p>
+          <a:p>
+            <a:pPr algn="ctr" indent="0" marL="0">
+              <a:buNone/>
+            </a:pPr>
+            <a:r>
+              <a:rPr lang="en-US" sz="1050" i="1" dirty="0">
+                <a:solidFill>
+                  <a:srgbClr val="1E2761"/>
+                </a:solidFill>
+                <a:latin typeface="Calibri" pitchFamily="34" charset="0"/>
+                <a:ea typeface="Calibri" pitchFamily="34" charset="-122"/>
+                <a:cs typeface="Calibri" pitchFamily="34" charset="-120"/>
+              </a:rPr>
+              <a:t>NPS (or CSAT) by Region</a:t>
+            </a:r>
+            <a:endParaRPr lang="en-US" sz="1300" dirty="0"/>
+          </a:p>
+          <a:p>
+            <a:pPr algn="ctr" indent="0" marL="0">
+              <a:buNone/>
+            </a:pPr>
+            <a:r>
+              <a:rPr lang="en-US" sz="1050" i="1" dirty="0">
+                <a:solidFill>
+                  <a:srgbClr val="1E2761"/>
+                </a:solidFill>
+                <a:latin typeface="Calibri" pitchFamily="34" charset="0"/>
+                <a:ea typeface="Calibri" pitchFamily="34" charset="-122"/>
+                <a:cs typeface="Calibri" pitchFamily="34" charset="-120"/>
+              </a:rPr>
+              <a:t>over time</a:t>
+            </a:r>
+            <a:endParaRPr lang="en-US" sz="1300" dirty="0"/>
+          </a:p>
+          <a:p>
+            <a:pPr algn="ctr" indent="0" marL="0">
+              <a:buNone/>
+            </a:pPr>
+            <a:r>
+              <a:rPr lang="en-US" sz="1050" i="1" dirty="0">
+                <a:solidFill>
+                  <a:srgbClr val="1E2761"/>
+                </a:solidFill>
+                <a:latin typeface="Calibri" pitchFamily="34" charset="0"/>
+                <a:ea typeface="Calibri" pitchFamily="34" charset="-122"/>
+                <a:cs typeface="Calibri" pitchFamily="34" charset="-120"/>
+              </a:rPr>
+              <a:t>(Customer_Experience sheet)</a:t>
+            </a:r>
+            <a:endParaRPr lang="en-US" sz="1300" dirty="0"/>
           </a:p>
         </p:txBody>
       </p:sp>
@@ -2494,53 +2688,24 @@
           <a:bodyPr wrap="square" lIns="0" tIns="0" rIns="0" bIns="0" rtlCol="0" anchor="t"/>
           <a:lstStyle/>
           <a:p>
-            <a:pPr marL="0" indent="0" algn="l">
+            <a:pPr algn="l" indent="0" marL="0">
               <a:buNone/>
               <a:defRPr sz="1200"/>
             </a:pPr>
             <a:r>
-              <a:rPr sz="1300" b="0">
-                <a:solidFill>
-                  <a:srgbClr val="000000"/>
-                </a:solidFill>
-              </a:rPr>
-              <a:t>• Average NPS: 49.75.</a:t>
+              <a:t>• APAC leads customer advocacy with NPS 62.</a:t>
             </a:r>
             <a:br/>
             <a:r>
-              <a:rPr sz="1300" b="0">
-                <a:solidFill>
-                  <a:srgbClr val="000000"/>
-                </a:solidFill>
-              </a:rPr>
-              <a:t>• Previous-quarter NPS: 49.25.</a:t>
+              <a:t>• Latin America trails significantly at NPS 29.</a:t>
             </a:r>
             <a:br/>
             <a:r>
-              <a:rPr sz="1300" b="0">
-                <a:solidFill>
-                  <a:srgbClr val="000000"/>
-                </a:solidFill>
-              </a:rPr>
-              <a:t>• NPS change: 0.50 points.</a:t>
+              <a:t>• Other regions remain stronger: North America (55), Europe (53).</a:t>
             </a:r>
             <a:br/>
             <a:r>
-              <a:rPr sz="1300" b="0">
-                <a:solidFill>
-                  <a:srgbClr val="000000"/>
-                </a:solidFill>
-              </a:rPr>
-              <a:t>• Average CSAT: 85.75%.</a:t>
-            </a:r>
-            <a:br/>
-            <a:r>
-              <a:rPr sz="1300" b="0">
-                <a:solidFill>
-                  <a:srgbClr val="000000"/>
-                </a:solidFill>
-              </a:rPr>
-              <a:t>• Monitor delivery days and support-ticket volume by region.</a:t>
+              <a:t>• Overall average NPS improved from 49.25 to 49.75, a +0.50-point QoQ change.</a:t>
             </a:r>
             <a:endParaRPr lang="en-US" sz="1350" dirty="0"/>
           </a:p>
@@ -2548,14 +2713,39 @@
       </p:sp>
       <p:sp>
         <p:nvSpPr>
-          <p:cNvPr id="8" name="footer_3"/>
+          <p:cNvPr id="6" name="icon_3"/>
+          <p:cNvSpPr/>
+          <p:nvPr/>
+        </p:nvSpPr>
+        <p:spPr>
+          <a:xfrm>
+            <a:off x="7543800" y="5166360"/>
+            <a:ext cx="1325880" cy="1051560"/>
+          </a:xfrm>
+          <a:prstGeom prst="roundRect">
+            <a:avLst>
+              <a:gd name="adj" fmla="val 6957"/>
+            </a:avLst>
+          </a:prstGeom>
+          <a:noFill/>
+          <a:ln w="22225">
+            <a:solidFill>
+              <a:srgbClr val="1E2761"/>
+            </a:solidFill>
+            <a:prstDash val="dash"/>
+          </a:ln>
+        </p:spPr>
+      </p:sp>
+      <p:sp>
+        <p:nvSpPr>
+          <p:cNvPr id="7" name="icon_3_label"/>
           <p:cNvSpPr txBox="1"/>
           <p:nvPr/>
         </p:nvSpPr>
         <p:spPr>
           <a:xfrm>
-            <a:off x="548640" y="6510528"/>
-            <a:ext cx="7315200" cy="274320"/>
+            <a:off x="7680960" y="5330952"/>
+            <a:ext cx="1051560" cy="722376"/>
           </a:xfrm>
           <a:prstGeom prst="rect">
             <a:avLst/>
@@ -2564,21 +2754,95 @@
           <a:ln/>
         </p:spPr>
         <p:txBody>
-          <a:bodyPr wrap="square" lIns="0" tIns="0" rIns="0" bIns="0" rtlCol="0" anchor="ctr"/>
-          <a:lstStyle/>
-          <a:p>
-            <a:pPr marL="0" indent="0" algn="l">
+          <a:bodyPr wrap="square" lIns="0" tIns="0" rIns="0" bIns="0" rtlCol="0" anchor="t"/>
+          <a:lstStyle/>
+          <a:p>
+            <a:pPr algn="ctr" indent="0" marL="0">
               <a:buNone/>
             </a:pPr>
             <a:r>
-              <a:rPr lang="en-US" sz="950" dirty="0">
-                <a:solidFill>
-                  <a:srgbClr val="5B6B8C"/>
+              <a:rPr lang="en-US" sz="1300" b="1" dirty="0">
+                <a:solidFill>
+                  <a:srgbClr val="1E2761"/>
                 </a:solidFill>
                 <a:latin typeface="Calibri" pitchFamily="34" charset="0"/>
                 <a:ea typeface="Calibri" pitchFamily="34" charset="-122"/>
                 <a:cs typeface="Calibri" pitchFamily="34" charset="-120"/>
               </a:rPr>
+              <a:t>ICON
+</a:t>
+            </a:r>
+            <a:endParaRPr lang="en-US" sz="1300" dirty="0"/>
+          </a:p>
+          <a:p>
+            <a:pPr algn="ctr" indent="0" marL="0">
+              <a:buNone/>
+            </a:pPr>
+            <a:r>
+              <a:rPr lang="en-US" sz="1050" i="1" dirty="0">
+                <a:solidFill>
+                  <a:srgbClr val="1E2761"/>
+                </a:solidFill>
+                <a:latin typeface="Calibri" pitchFamily="34" charset="0"/>
+                <a:ea typeface="Calibri" pitchFamily="34" charset="-122"/>
+                <a:cs typeface="Calibri" pitchFamily="34" charset="-120"/>
+              </a:rPr>
+              <a:t>Pick the icon for</a:t>
+            </a:r>
+            <a:endParaRPr lang="en-US" sz="1300" dirty="0"/>
+          </a:p>
+          <a:p>
+            <a:pPr algn="ctr" indent="0" marL="0">
+              <a:buNone/>
+            </a:pPr>
+            <a:r>
+              <a:rPr lang="en-US" sz="1050" i="1" dirty="0">
+                <a:solidFill>
+                  <a:srgbClr val="1E2761"/>
+                </a:solidFill>
+                <a:latin typeface="Calibri" pitchFamily="34" charset="0"/>
+                <a:ea typeface="Calibri" pitchFamily="34" charset="-122"/>
+                <a:cs typeface="Calibri" pitchFamily="34" charset="-120"/>
+              </a:rPr>
+              <a:t>customer experience</a:t>
+            </a:r>
+            <a:endParaRPr lang="en-US" sz="1300" dirty="0"/>
+          </a:p>
+        </p:txBody>
+      </p:sp>
+      <p:sp>
+        <p:nvSpPr>
+          <p:cNvPr id="8" name="footer_3"/>
+          <p:cNvSpPr txBox="1"/>
+          <p:nvPr/>
+        </p:nvSpPr>
+        <p:spPr>
+          <a:xfrm>
+            <a:off x="548640" y="6510528"/>
+            <a:ext cx="7315200" cy="274320"/>
+          </a:xfrm>
+          <a:prstGeom prst="rect">
+            <a:avLst/>
+          </a:prstGeom>
+          <a:noFill/>
+          <a:ln/>
+        </p:spPr>
+        <p:txBody>
+          <a:bodyPr wrap="square" lIns="0" tIns="0" rIns="0" bIns="0" rtlCol="0" anchor="ctr"/>
+          <a:lstStyle/>
+          <a:p>
+            <a:pPr algn="l" indent="0" marL="0">
+              <a:buNone/>
+            </a:pPr>
+            <a:r>
+              <a:rPr lang="en-US" sz="950" dirty="0">
+                <a:solidFill>
+                  <a:srgbClr val="5B6B8C"/>
+                </a:solidFill>
+                <a:latin typeface="Calibri" pitchFamily="34" charset="0"/>
+                <a:ea typeface="Calibri" pitchFamily="34" charset="-122"/>
+                <a:cs typeface="Calibri" pitchFamily="34" charset="-120"/>
+              </a:rPr>
               <a:t>NovaRetail Quarterly Business Review  —  Capstone Template</a:t>
             </a:r>
             <a:endParaRPr lang="en-US" sz="950" dirty="0"/>
@@ -2606,7 +2870,7 @@
           <a:bodyPr wrap="square" lIns="0" tIns="0" rIns="0" bIns="0" rtlCol="0" anchor="ctr"/>
           <a:lstStyle/>
           <a:p>
-            <a:pPr marL="0" indent="0" algn="r">
+            <a:pPr algn="r" indent="0" marL="0">
               <a:buNone/>
             </a:pPr>
             <a:r>
@@ -2638,34 +2902,10 @@
         </p:xfrm>
         <a:graphic>
           <a:graphicData uri="http://schemas.openxmlformats.org/drawingml/2006/chart">
-            <c:chart xmlns:c="http://schemas.openxmlformats.org/drawingml/2006/chart" xmlns:r="http://schemas.openxmlformats.org/officeDocument/2006/relationships" r:id="rId3"/>
+            <c:chart xmlns:c="http://schemas.openxmlformats.org/drawingml/2006/chart" r:id="rId3"/>
           </a:graphicData>
         </a:graphic>
       </p:graphicFrame>
-      <p:pic>
-        <p:nvPicPr>
-          <p:cNvPr id="11" name="Picture 10" descr="customer_star.png"/>
-          <p:cNvPicPr>
-            <a:picLocks noChangeAspect="1"/>
-          </p:cNvPicPr>
-          <p:nvPr/>
-        </p:nvPicPr>
-        <p:blipFill>
-          <a:blip r:embed="rId4"/>
-          <a:stretch>
-            <a:fillRect/>
-          </a:stretch>
-        </p:blipFill>
-        <p:spPr>
-          <a:xfrm>
-            <a:off x="7795260" y="5280660"/>
-            <a:ext cx="822960" cy="822960"/>
-          </a:xfrm>
-          <a:prstGeom prst="rect">
-            <a:avLst/>
-          </a:prstGeom>
-        </p:spPr>
-      </p:pic>
     </p:spTree>
   </p:cSld>
   <p:clrMapOvr>
@@ -2682,7 +2922,6 @@
         <a:solidFill>
           <a:srgbClr val="FFFFFF"/>
         </a:solidFill>
-        <a:effectLst/>
       </p:bgPr>
     </p:bg>
     <p:spTree>
@@ -2720,7 +2959,7 @@
           <a:bodyPr wrap="square" lIns="0" tIns="0" rIns="0" bIns="0" rtlCol="0" anchor="t"/>
           <a:lstStyle/>
           <a:p>
-            <a:pPr marL="0" indent="0" algn="l">
+            <a:pPr algn="l" indent="0" marL="0">
               <a:buNone/>
               <a:defRPr sz="1200"/>
             </a:pPr>
@@ -2757,7 +2996,7 @@
           <a:bodyPr wrap="square" lIns="0" tIns="0" rIns="0" bIns="0" rtlCol="0" anchor="t"/>
           <a:lstStyle/>
           <a:p>
-            <a:pPr marL="0" indent="0" algn="l">
+            <a:pPr algn="l" indent="0" marL="0">
               <a:buNone/>
               <a:defRPr sz="1200"/>
             </a:pPr>
@@ -2821,7 +3060,7 @@
           <a:bodyPr wrap="square" lIns="0" tIns="0" rIns="0" bIns="0" rtlCol="0" anchor="ctr"/>
           <a:lstStyle/>
           <a:p>
-            <a:pPr marL="0" indent="0" algn="l">
+            <a:pPr algn="l" indent="0" marL="0">
               <a:buNone/>
             </a:pPr>
             <a:r>
@@ -2860,7 +3099,7 @@
           <a:bodyPr wrap="square" lIns="0" tIns="0" rIns="0" bIns="0" rtlCol="0" anchor="ctr"/>
           <a:lstStyle/>
           <a:p>
-            <a:pPr marL="0" indent="0" algn="r">
+            <a:pPr algn="r" indent="0" marL="0">
               <a:buNone/>
             </a:pPr>
             <a:r>
@@ -2892,7 +3131,7 @@
         </p:xfrm>
         <a:graphic>
           <a:graphicData uri="http://schemas.openxmlformats.org/drawingml/2006/chart">
-            <c:chart xmlns:c="http://schemas.openxmlformats.org/drawingml/2006/chart" xmlns:r="http://schemas.openxmlformats.org/officeDocument/2006/relationships" r:id="rId3"/>
+            <c:chart xmlns:c="http://schemas.openxmlformats.org/drawingml/2006/chart" r:id="rId3"/>
           </a:graphicData>
         </a:graphic>
       </p:graphicFrame>
@@ -2936,7 +3175,6 @@
         <a:solidFill>
           <a:srgbClr val="1E2761"/>
         </a:solidFill>
-        <a:effectLst/>
       </p:bgPr>
     </p:bg>
     <p:spTree>
@@ -2974,7 +3212,7 @@
           <a:bodyPr wrap="square" lIns="0" tIns="0" rIns="0" bIns="0" rtlCol="0" anchor="ctr"/>
           <a:lstStyle/>
           <a:p>
-            <a:pPr marL="0" indent="0" algn="l">
+            <a:pPr algn="l" indent="0" marL="0">
               <a:buNone/>
             </a:pPr>
             <a:r>
@@ -3013,7 +3251,7 @@
           <a:bodyPr wrap="square" lIns="0" tIns="0" rIns="0" bIns="0" rtlCol="0" anchor="t"/>
           <a:lstStyle/>
           <a:p>
-            <a:pPr marL="0" indent="0" algn="l">
+            <a:pPr algn="l" indent="0" marL="0">
               <a:buNone/>
               <a:defRPr sz="1200"/>
             </a:pPr>
@@ -3080,7 +3318,7 @@
           <a:bodyPr wrap="square" lIns="0" tIns="0" rIns="0" bIns="0" rtlCol="0" anchor="t"/>
           <a:lstStyle/>
           <a:p>
-            <a:pPr marL="0" indent="0" algn="l">
+            <a:pPr algn="l" indent="0" marL="0">
               <a:buNone/>
               <a:defRPr sz="1200"/>
             </a:pPr>
@@ -3117,7 +3355,7 @@
           <a:bodyPr wrap="square" lIns="0" tIns="0" rIns="0" bIns="0" rtlCol="0" anchor="ctr"/>
           <a:lstStyle/>
           <a:p>
-            <a:pPr marL="0" indent="0" algn="l">
+            <a:pPr algn="l" indent="0" marL="0">
               <a:buNone/>
             </a:pPr>
             <a:r>
@@ -3156,7 +3394,7 @@
           <a:bodyPr wrap="square" lIns="0" tIns="0" rIns="0" bIns="0" rtlCol="0" anchor="ctr"/>
           <a:lstStyle/>
           <a:p>
-            <a:pPr marL="0" indent="0" algn="r">
+            <a:pPr algn="r" indent="0" marL="0">
               <a:buNone/>
             </a:pPr>
             <a:r>
@@ -3499,325 +3737,4 @@
     </a:ext>
   </a:extLst>
 </a:theme>
-</file>
-
-<file path=ppt/theme/theme2.xml><?xml version="1.0" encoding="utf-8"?>
-<a:theme xmlns:a="http://schemas.openxmlformats.org/drawingml/2006/main" name="Office Theme">
-  <a:themeElements>
-    <a:clrScheme name="Office">
-      <a:dk1>
-        <a:sysClr val="windowText" lastClr="000000"/>
-      </a:dk1>
-      <a:lt1>
-        <a:sysClr val="window" lastClr="FFFFFF"/>
-      </a:lt1>
-      <a:dk2>
-        <a:srgbClr val="0E2841"/>
-      </a:dk2>
-      <a:lt2>
-        <a:srgbClr val="E8E8E8"/>
-      </a:lt2>
-      <a:accent1>
-        <a:srgbClr val="156082"/>
-      </a:accent1>
-      <a:accent2>
-        <a:srgbClr val="E97132"/>
-      </a:accent2>
-      <a:accent3>
-        <a:srgbClr val="196B24"/>
-      </a:accent3>
-      <a:accent4>
-        <a:srgbClr val="0F9ED5"/>
-      </a:accent4>
-      <a:accent5>
-        <a:srgbClr val="A02B93"/>
-      </a:accent5>
-      <a:accent6>
-        <a:srgbClr val="4EA72E"/>
-      </a:accent6>
-      <a:hlink>
-        <a:srgbClr val="467886"/>
-      </a:hlink>
-      <a:folHlink>
-        <a:srgbClr val="96607D"/>
-      </a:folHlink>
-    </a:clrScheme>
-    <a:fontScheme name="Office">
-      <a:majorFont>
-        <a:latin typeface="Aptos Display" panose="02110004020202020204"/>
-        <a:ea typeface=""/>
-        <a:cs typeface=""/>
-        <a:font script="Jpan" typeface="游ゴシック Light"/>
-        <a:font script="Hang" typeface="맑은 고딕"/>
-        <a:font script="Hans" typeface="等线 Light"/>
-        <a:font script="Hant" typeface="新細明體"/>
-        <a:font script="Arab" typeface="Times New Roman"/>
-        <a:font script="Hebr" typeface="Times New Roman"/>
-        <a:font script="Thai" typeface="Angsana New"/>
-        <a:font script="Ethi" typeface="Nyala"/>
-        <a:font script="Beng" typeface="Vrinda"/>
-        <a:font script="Gujr" typeface="Shruti"/>
-        <a:font script="Khmr" typeface="MoolBoran"/>
-        <a:font script="Knda" typeface="Tunga"/>
-        <a:font script="Guru" typeface="Raavi"/>
-        <a:font script="Cans" typeface="Euphemia"/>
-        <a:font script="Cher" typeface="Plantagenet Cherokee"/>
-        <a:font script="Yiii" typeface="Microsoft Yi Baiti"/>
-        <a:font script="Tibt" typeface="Microsoft Himalaya"/>
-        <a:font script="Thaa" typeface="MV Boli"/>
-        <a:font script="Deva" typeface="Mangal"/>
-        <a:font script="Telu" typeface="Gautami"/>
-        <a:font script="Taml" typeface="Latha"/>
-        <a:font script="Syrc" typeface="Estrangelo Edessa"/>
-        <a:font script="Orya" typeface="Kalinga"/>
-        <a:font script="Mlym" typeface="Kartika"/>
-        <a:font script="Laoo" typeface="DokChampa"/>
-        <a:font script="Sinh" typeface="Iskoola Pota"/>
-        <a:font script="Mong" typeface="Mongolian Baiti"/>
-        <a:font script="Viet" typeface="Times New Roman"/>
-        <a:font script="Uigh" typeface="Microsoft Uighur"/>
-        <a:font script="Geor" typeface="Sylfaen"/>
-        <a:font script="Armn" typeface="Arial"/>
-        <a:font script="Bugi" typeface="Leelawadee UI"/>
-        <a:font script="Bopo" typeface="Microsoft JhengHei"/>
-        <a:font script="Java" typeface="Javanese Text"/>
-        <a:font script="Lisu" typeface="Segoe UI"/>
-        <a:font script="Mymr" typeface="Myanmar Text"/>
-        <a:font script="Nkoo" typeface="Ebrima"/>
-        <a:font script="Olck" typeface="Nirmala UI"/>
-        <a:font script="Osma" typeface="Ebrima"/>
-        <a:font script="Phag" typeface="Phagspa"/>
-        <a:font script="Syrn" typeface="Estrangelo Edessa"/>
-        <a:font script="Syrj" typeface="Estrangelo Edessa"/>
-        <a:font script="Syre" typeface="Estrangelo Edessa"/>
-        <a:font script="Sora" typeface="Nirmala UI"/>
-        <a:font script="Tale" typeface="Microsoft Tai Le"/>
-        <a:font script="Talu" typeface="Microsoft New Tai Lue"/>
-        <a:font script="Tfng" typeface="Ebrima"/>
-      </a:majorFont>
-      <a:minorFont>
-        <a:latin typeface="Aptos" panose="02110004020202020204"/>
-        <a:ea typeface=""/>
-        <a:cs typeface=""/>
-        <a:font script="Jpan" typeface="游ゴシック"/>
-        <a:font script="Hang" typeface="맑은 고딕"/>
-        <a:font script="Hans" typeface="等线"/>
-        <a:font script="Hant" typeface="新細明體"/>
-        <a:font script="Arab" typeface="Arial"/>
-        <a:font script="Hebr" typeface="Arial"/>
-        <a:font script="Thai" typeface="Cordia New"/>
-        <a:font script="Ethi" typeface="Nyala"/>
-        <a:font script="Beng" typeface="Vrinda"/>
-        <a:font script="Gujr" typeface="Shruti"/>
-        <a:font script="Khmr" typeface="DaunPenh"/>
-        <a:font script="Knda" typeface="Tunga"/>
-        <a:font script="Guru" typeface="Raavi"/>
-        <a:font script="Cans" typeface="Euphemia"/>
-        <a:font script="Cher" typeface="Plantagenet Cherokee"/>
-        <a:font script="Yiii" typeface="Microsoft Yi Baiti"/>
-        <a:font script="Tibt" typeface="Microsoft Himalaya"/>
-        <a:font script="Thaa" typeface="MV Boli"/>
-        <a:font script="Deva" typeface="Mangal"/>
-        <a:font script="Telu" typeface="Gautami"/>
-        <a:font script="Taml" typeface="Latha"/>
-        <a:font script="Syrc" typeface="Estrangelo Edessa"/>
-        <a:font script="Orya" typeface="Kalinga"/>
-        <a:font script="Mlym" typeface="Kartika"/>
-        <a:font script="Laoo" typeface="DokChampa"/>
-        <a:font script="Sinh" typeface="Iskoola Pota"/>
-        <a:font script="Mong" typeface="Mongolian Baiti"/>
-        <a:font script="Viet" typeface="Arial"/>
-        <a:font script="Uigh" typeface="Microsoft Uighur"/>
-        <a:font script="Geor" typeface="Sylfaen"/>
-        <a:font script="Armn" typeface="Arial"/>
-        <a:font script="Bugi" typeface="Leelawadee UI"/>
-        <a:font script="Bopo" typeface="Microsoft JhengHei"/>
-        <a:font script="Java" typeface="Javanese Text"/>
-        <a:font script="Lisu" typeface="Segoe UI"/>
-        <a:font script="Mymr" typeface="Myanmar Text"/>
-        <a:font script="Nkoo" typeface="Ebrima"/>
-        <a:font script="Olck" typeface="Nirmala UI"/>
-        <a:font script="Osma" typeface="Ebrima"/>
-        <a:font script="Phag" typeface="Phagspa"/>
-        <a:font script="Syrn" typeface="Estrangelo Edessa"/>
-        <a:font script="Syrj" typeface="Estrangelo Edessa"/>
-        <a:font script="Syre" typeface="Estrangelo Edessa"/>
-        <a:font script="Sora" typeface="Nirmala UI"/>
-        <a:font script="Tale" typeface="Microsoft Tai Le"/>
-        <a:font script="Talu" typeface="Microsoft New Tai Lue"/>
-        <a:font script="Tfng" typeface="Ebrima"/>
-      </a:minorFont>
-    </a:fontScheme>
-    <a:fmtScheme name="Office">
-      <a:fillStyleLst>
-        <a:solidFill>
-          <a:schemeClr val="phClr"/>
-        </a:solidFill>
-        <a:gradFill rotWithShape="1">
-          <a:gsLst>
-            <a:gs pos="0">
-              <a:schemeClr val="phClr">
-                <a:lumMod val="110000"/>
-                <a:satMod val="105000"/>
-                <a:tint val="67000"/>
-              </a:schemeClr>
-            </a:gs>
-            <a:gs pos="50000">
-              <a:schemeClr val="phClr">
-                <a:lumMod val="105000"/>
-                <a:satMod val="103000"/>
-                <a:tint val="73000"/>
-              </a:schemeClr>
-            </a:gs>
-            <a:gs pos="100000">
-              <a:schemeClr val="phClr">
-                <a:lumMod val="105000"/>
-                <a:satMod val="109000"/>
-                <a:tint val="81000"/>
-              </a:schemeClr>
-            </a:gs>
-          </a:gsLst>
-          <a:lin ang="5400000" scaled="0"/>
-        </a:gradFill>
-        <a:gradFill rotWithShape="1">
-          <a:gsLst>
-            <a:gs pos="0">
-              <a:schemeClr val="phClr">
-                <a:satMod val="103000"/>
-                <a:lumMod val="102000"/>
-                <a:tint val="94000"/>
-              </a:schemeClr>
-            </a:gs>
-            <a:gs pos="50000">
-              <a:schemeClr val="phClr">
-                <a:satMod val="110000"/>
-                <a:lumMod val="100000"/>
-                <a:shade val="100000"/>
-              </a:schemeClr>
-            </a:gs>
-            <a:gs pos="100000">
-              <a:schemeClr val="phClr">
-                <a:lumMod val="99000"/>
-                <a:satMod val="120000"/>
-                <a:shade val="78000"/>
-              </a:schemeClr>
-            </a:gs>
-          </a:gsLst>
-          <a:lin ang="5400000" scaled="0"/>
-        </a:gradFill>
-      </a:fillStyleLst>
-      <a:lnStyleLst>
-        <a:ln w="12700" cap="flat" cmpd="sng" algn="ctr">
-          <a:solidFill>
-            <a:schemeClr val="phClr"/>
-          </a:solidFill>
-          <a:prstDash val="solid"/>
-          <a:miter lim="800000"/>
-        </a:ln>
-        <a:ln w="19050" cap="flat" cmpd="sng" algn="ctr">
-          <a:solidFill>
-            <a:schemeClr val="phClr"/>
-          </a:solidFill>
-          <a:prstDash val="solid"/>
-          <a:miter lim="800000"/>
-        </a:ln>
-        <a:ln w="25400" cap="flat" cmpd="sng" algn="ctr">
-          <a:solidFill>
-            <a:schemeClr val="phClr"/>
-          </a:solidFill>
-          <a:prstDash val="solid"/>
-          <a:miter lim="800000"/>
-        </a:ln>
-      </a:lnStyleLst>
-      <a:effectStyleLst>
-        <a:effectStyle>
-          <a:effectLst/>
-        </a:effectStyle>
-        <a:effectStyle>
-          <a:effectLst/>
-        </a:effectStyle>
-        <a:effectStyle>
-          <a:effectLst>
-            <a:outerShdw blurRad="57150" dist="19050" dir="5400000" algn="ctr" rotWithShape="0">
-              <a:srgbClr val="000000">
-                <a:alpha val="63000"/>
-              </a:srgbClr>
-            </a:outerShdw>
-          </a:effectLst>
-        </a:effectStyle>
-      </a:effectStyleLst>
-      <a:bgFillStyleLst>
-        <a:solidFill>
-          <a:schemeClr val="phClr"/>
-        </a:solidFill>
-        <a:solidFill>
-          <a:schemeClr val="phClr">
-            <a:tint val="95000"/>
-            <a:satMod val="170000"/>
-          </a:schemeClr>
-        </a:solidFill>
-        <a:gradFill rotWithShape="1">
-          <a:gsLst>
-            <a:gs pos="0">
-              <a:schemeClr val="phClr">
-                <a:tint val="93000"/>
-                <a:satMod val="150000"/>
-                <a:shade val="98000"/>
-                <a:lumMod val="102000"/>
-              </a:schemeClr>
-            </a:gs>
-            <a:gs pos="50000">
-              <a:schemeClr val="phClr">
-                <a:tint val="98000"/>
-                <a:satMod val="130000"/>
-                <a:shade val="90000"/>
-                <a:lumMod val="103000"/>
-              </a:schemeClr>
-            </a:gs>
-            <a:gs pos="100000">
-              <a:schemeClr val="phClr">
-                <a:shade val="63000"/>
-                <a:satMod val="120000"/>
-              </a:schemeClr>
-            </a:gs>
-          </a:gsLst>
-          <a:lin ang="5400000" scaled="0"/>
-        </a:gradFill>
-      </a:bgFillStyleLst>
-    </a:fmtScheme>
-  </a:themeElements>
-  <a:objectDefaults>
-    <a:lnDef>
-      <a:spPr/>
-      <a:bodyPr/>
-      <a:lstStyle/>
-      <a:style>
-        <a:lnRef idx="2">
-          <a:schemeClr val="accent1"/>
-        </a:lnRef>
-        <a:fillRef idx="0">
-          <a:schemeClr val="accent1"/>
-        </a:fillRef>
-        <a:effectRef idx="1">
-          <a:schemeClr val="accent1"/>
-        </a:effectRef>
-        <a:fontRef idx="minor">
-          <a:schemeClr val="tx1"/>
-        </a:fontRef>
-      </a:style>
-    </a:lnDef>
-  </a:objectDefaults>
-  <a:extraClrSchemeLst/>
-  <a:extLst>
-    <a:ext uri="{05A4C25C-085E-4340-85A3-A5531E510DB2}">
-      <thm15:themeFamily xmlns:thm15="http://schemas.microsoft.com/office/thememl/2012/main" name="Office Theme" id="{2E142A2C-CD16-42D6-873A-C26D2A0506FA}" vid="{1BDDFF52-6CD6-40A5-AB3C-68EB2F1E4D0A}"/>
-    </a:ext>
-  </a:extLst>
-</a:theme>
-</file>
-
-<file path=docMetadata/LabelInfo.xml><?xml version="1.0" encoding="utf-8"?>
-<clbl:labelList xmlns:clbl="http://schemas.microsoft.com/office/2020/mipLabelMetadata">
-  <clbl:label id="{27f6b194-73f8-48d3-95d2-0d2530a9bb45}" enabled="1" method="Standard" siteId="{0483ae51-a627-466e-a7dd-de2ac7e1238e}" contentBits="2" removed="0"/>
-</clbl:labelList>
 </file>
</xml_diff>